<commit_message>
style: apply official RMUTL Golden Brown palette across design system and dashboard UI
</commit_message>
<xml_diff>
--- a/LLM_Presentation.pptx
+++ b/LLM_Presentation.pptx
@@ -7636,8 +7636,8 @@
         </p:nvSpPr>
         <p:spPr>
           <a:xfrm>
-            <a:off x="822960" y="5567680"/>
-            <a:ext cx="10515600" cy="312928"/>
+            <a:off x="822960" y="5554098"/>
+            <a:ext cx="10515600" cy="340093"/>
           </a:xfrm>
           <a:prstGeom prst="rect">
             <a:avLst/>
@@ -7662,13 +7662,112 @@
               </a:spcAft>
             </a:pPr>
             <a:r>
-              <a:rPr sz="1400" b="0" i="0">
+              <a:rPr sz="1400" b="0" i="0" dirty="0" err="1">
                 <a:solidFill>
                   <a:srgbClr val="D6D3D1"/>
                 </a:solidFill>
                 <a:latin typeface="Prompt"/>
               </a:rPr>
-              <a:t>ขอบเขต: จำแนกแบบทวิภาค (บวก/ลบ)  ·  ชุดข้อมูลสมดุล  ·  วัดผลด้วย Accuracy, Precision, Recall, F1</a:t>
+              <a:t>ขอบเขต</a:t>
+            </a:r>
+            <a:r>
+              <a:rPr sz="1400" b="0" i="0" dirty="0">
+                <a:solidFill>
+                  <a:srgbClr val="D6D3D1"/>
+                </a:solidFill>
+                <a:latin typeface="Prompt"/>
+              </a:rPr>
+              <a:t>: </a:t>
+            </a:r>
+            <a:r>
+              <a:rPr sz="1400" b="0" i="0" dirty="0" err="1">
+                <a:solidFill>
+                  <a:srgbClr val="D6D3D1"/>
+                </a:solidFill>
+                <a:latin typeface="Prompt"/>
+              </a:rPr>
+              <a:t>จำแนกแบบทวิภาค</a:t>
+            </a:r>
+            <a:r>
+              <a:rPr sz="1400" b="0" i="0" dirty="0">
+                <a:solidFill>
+                  <a:srgbClr val="D6D3D1"/>
+                </a:solidFill>
+                <a:latin typeface="Prompt"/>
+              </a:rPr>
+              <a:t> (</a:t>
+            </a:r>
+            <a:r>
+              <a:rPr sz="1400" b="0" i="0" dirty="0" err="1">
+                <a:solidFill>
+                  <a:srgbClr val="D6D3D1"/>
+                </a:solidFill>
+                <a:latin typeface="Prompt"/>
+              </a:rPr>
+              <a:t>บวก</a:t>
+            </a:r>
+            <a:r>
+              <a:rPr sz="1400" b="0" i="0" dirty="0">
+                <a:solidFill>
+                  <a:srgbClr val="D6D3D1"/>
+                </a:solidFill>
+                <a:latin typeface="Prompt"/>
+              </a:rPr>
+              <a:t>/</a:t>
+            </a:r>
+            <a:r>
+              <a:rPr sz="1400" b="0" i="0" dirty="0" err="1">
+                <a:solidFill>
+                  <a:srgbClr val="D6D3D1"/>
+                </a:solidFill>
+                <a:latin typeface="Prompt"/>
+              </a:rPr>
+              <a:t>ลบ</a:t>
+            </a:r>
+            <a:r>
+              <a:rPr sz="1400" b="0" i="0" dirty="0">
+                <a:solidFill>
+                  <a:srgbClr val="D6D3D1"/>
+                </a:solidFill>
+                <a:latin typeface="Prompt"/>
+              </a:rPr>
+              <a:t>)  ·  </a:t>
+            </a:r>
+            <a:r>
+              <a:rPr sz="1400" b="0" i="0" dirty="0" err="1">
+                <a:solidFill>
+                  <a:srgbClr val="D6D3D1"/>
+                </a:solidFill>
+                <a:latin typeface="Prompt"/>
+              </a:rPr>
+              <a:t>ชุดข้อมูลสมดุล</a:t>
+            </a:r>
+            <a:r>
+              <a:rPr sz="1400" b="0" i="0" dirty="0">
+                <a:solidFill>
+                  <a:srgbClr val="D6D3D1"/>
+                </a:solidFill>
+                <a:latin typeface="Prompt"/>
+              </a:rPr>
+              <a:t>  ·  </a:t>
+            </a:r>
+            <a:r>
+              <a:rPr sz="1400" b="0" i="0" dirty="0" err="1">
+                <a:solidFill>
+                  <a:srgbClr val="D6D3D1"/>
+                </a:solidFill>
+                <a:latin typeface="Prompt"/>
+              </a:rPr>
+              <a:t>วัดผลด้วย</a:t>
+            </a:r>
+            <a:r>
+              <a:rPr sz="1400" b="0" i="0" dirty="0">
+                <a:solidFill>
+                  <a:srgbClr val="D6D3D1"/>
+                </a:solidFill>
+                <a:latin typeface="Prompt"/>
+              </a:rPr>
+              <a:t> Accuracy, Precision, Recall, F1</a:t>
             </a:r>
           </a:p>
         </p:txBody>
@@ -8007,7 +8106,7 @@
               </a:spcAft>
             </a:pPr>
             <a:r>
-              <a:rPr sz="1500" b="1" i="0">
+              <a:rPr sz="1500" b="1" i="0" dirty="0">
                 <a:solidFill>
                   <a:srgbClr val="F59E0B"/>
                 </a:solidFill>
@@ -8016,14 +8115,29 @@
               <a:t>02  ·  </a:t>
             </a:r>
             <a:r>
-              <a:rPr sz="3000" b="1" i="0">
+              <a:rPr sz="3000" b="1" i="0" dirty="0">
                 <a:solidFill>
                   <a:srgbClr val="FAFAF9"/>
                 </a:solidFill>
                 <a:latin typeface="Prompt"/>
               </a:rPr>
-              <a:t>LSTM: หน่วยความจำแบบวนซ้ำ</a:t>
-            </a:r>
+              <a:t>LSTM: </a:t>
+            </a:r>
+            <a:r>
+              <a:rPr sz="3000" b="1" i="0" dirty="0" err="1">
+                <a:solidFill>
+                  <a:srgbClr val="FAFAF9"/>
+                </a:solidFill>
+                <a:latin typeface="Prompt"/>
+              </a:rPr>
+              <a:t>หน่วยความจำแบบวนซ้ำ</a:t>
+            </a:r>
+            <a:endParaRPr sz="3000" b="1" i="0" dirty="0">
+              <a:solidFill>
+                <a:srgbClr val="FAFAF9"/>
+              </a:solidFill>
+              <a:latin typeface="Prompt"/>
+            </a:endParaRPr>
           </a:p>
           <a:p>
             <a:pPr algn="l">
@@ -8038,7 +8152,7 @@
               </a:spcAft>
             </a:pPr>
             <a:r>
-              <a:rPr sz="1400" b="0" i="1">
+              <a:rPr sz="1400" b="0" i="1" dirty="0">
                 <a:solidFill>
                   <a:srgbClr val="A8A29E"/>
                 </a:solidFill>
@@ -11305,7 +11419,7 @@
               </a:spcAft>
             </a:pPr>
             <a:r>
-              <a:rPr sz="1500" b="1" i="0">
+              <a:rPr sz="1500" b="1" i="0" dirty="0">
                 <a:solidFill>
                   <a:srgbClr val="34D399"/>
                 </a:solidFill>
@@ -11327,14 +11441,29 @@
               </a:spcAft>
             </a:pPr>
             <a:r>
-              <a:rPr sz="1600" b="1" i="0">
+              <a:rPr sz="1600" b="1" i="0" dirty="0">
                 <a:solidFill>
                   <a:srgbClr val="FAFAF9"/>
                 </a:solidFill>
                 <a:latin typeface="Prompt"/>
               </a:rPr>
-              <a:t>BERT 12 ชั้น</a:t>
-            </a:r>
+              <a:t>BERT 12 </a:t>
+            </a:r>
+            <a:r>
+              <a:rPr sz="1600" b="1" i="0" dirty="0" err="1">
+                <a:solidFill>
+                  <a:srgbClr val="FAFAF9"/>
+                </a:solidFill>
+                <a:latin typeface="Prompt"/>
+              </a:rPr>
+              <a:t>ชั้น</a:t>
+            </a:r>
+            <a:endParaRPr sz="1600" b="1" i="0" dirty="0">
+              <a:solidFill>
+                <a:srgbClr val="FAFAF9"/>
+              </a:solidFill>
+              <a:latin typeface="Prompt"/>
+            </a:endParaRPr>
           </a:p>
           <a:p>
             <a:pPr algn="l">
@@ -11349,14 +11478,59 @@
               </a:spcAft>
             </a:pPr>
             <a:r>
-              <a:rPr sz="1350" b="0" i="0">
+              <a:rPr sz="1350" b="0" i="0" dirty="0" err="1">
                 <a:solidFill>
                   <a:srgbClr val="D6D3D1"/>
                 </a:solidFill>
                 <a:latin typeface="Prompt"/>
               </a:rPr>
-              <a:t>สกัดเวกเตอร์ 768 มิติ
-จาก [CLS]</a:t>
+              <a:t>สกัดเวกเตอร์</a:t>
+            </a:r>
+            <a:r>
+              <a:rPr sz="1350" b="0" i="0" dirty="0">
+                <a:solidFill>
+                  <a:srgbClr val="D6D3D1"/>
+                </a:solidFill>
+                <a:latin typeface="Prompt"/>
+              </a:rPr>
+              <a:t> 768 </a:t>
+            </a:r>
+            <a:r>
+              <a:rPr sz="1350" b="0" i="0" dirty="0" err="1">
+                <a:solidFill>
+                  <a:srgbClr val="D6D3D1"/>
+                </a:solidFill>
+                <a:latin typeface="Prompt"/>
+              </a:rPr>
+              <a:t>มิติ</a:t>
+            </a:r>
+            <a:r>
+              <a:rPr sz="1350" b="0" i="0" dirty="0">
+                <a:solidFill>
+                  <a:srgbClr val="D6D3D1"/>
+                </a:solidFill>
+                <a:latin typeface="Prompt"/>
+              </a:rPr>
+              <a:t>
+</a:t>
+            </a:r>
+            <a:r>
+              <a:rPr sz="1350" b="0" i="0" dirty="0" err="1">
+                <a:solidFill>
+                  <a:srgbClr val="D6D3D1"/>
+                </a:solidFill>
+                <a:latin typeface="Prompt"/>
+              </a:rPr>
+              <a:t>จาก</a:t>
+            </a:r>
+            <a:r>
+              <a:rPr sz="1350" b="0" i="0" dirty="0">
+                <a:solidFill>
+                  <a:srgbClr val="D6D3D1"/>
+                </a:solidFill>
+                <a:latin typeface="Prompt"/>
+              </a:rPr>
+              <a:t> [CLS]</a:t>
             </a:r>
           </a:p>
         </p:txBody>

</xml_diff>

<commit_message>
feat(math): implement academic two-tier fractions, subscripts, and interactive metric derivation cards
</commit_message>
<xml_diff>
--- a/LLM_Presentation.pptx
+++ b/LLM_Presentation.pptx
@@ -6844,87 +6844,6 @@
       </p:sp>
       <p:sp>
         <p:nvSpPr>
-          <p:cNvPr id="7" name="TextBox 6"/>
-          <p:cNvSpPr txBox="1"/>
-          <p:nvPr/>
-        </p:nvSpPr>
-        <p:spPr>
-          <a:xfrm>
-            <a:off x="548640" y="6053328"/>
-            <a:ext cx="11091672" cy="365760"/>
-          </a:xfrm>
-          <a:prstGeom prst="rect">
-            <a:avLst/>
-          </a:prstGeom>
-          <a:noFill/>
-        </p:spPr>
-        <p:txBody>
-          <a:bodyPr wrap="square">
-            <a:spAutoFit/>
-          </a:bodyPr>
-          <a:lstStyle/>
-          <a:p>
-            <a:pPr algn="ctr">
-              <a:lnSpc>
-                <a:spcPct val="115000"/>
-              </a:lnSpc>
-              <a:spcBef>
-                <a:spcPts val="0"/>
-              </a:spcBef>
-              <a:spcAft>
-                <a:spcPts val="600"/>
-              </a:spcAft>
-            </a:pPr>
-            <a:r>
-              <a:rPr sz="1150" b="1" i="0">
-                <a:solidFill>
-                  <a:srgbClr val="FBBF24"/>
-                </a:solidFill>
-                <a:latin typeface="Prompt"/>
-              </a:rPr>
-              <a:t>ศัพท์น่ารู้  </a:t>
-            </a:r>
-            <a:r>
-              <a:rPr sz="1150" b="1" i="0">
-                <a:solidFill>
-                  <a:srgbClr val="FAFAF9"/>
-                </a:solidFill>
-                <a:latin typeface="Prompt"/>
-              </a:rPr>
-              <a:t>et al.</a:t>
-            </a:r>
-            <a:r>
-              <a:rPr sz="1150" b="0" i="0">
-                <a:solidFill>
-                  <a:srgbClr val="A8A29E"/>
-                </a:solidFill>
-                <a:latin typeface="Prompt"/>
-              </a:rPr>
-              <a:t> = และคณะ (ผู้เขียนร่วม)   ·   </a:t>
-            </a:r>
-            <a:r>
-              <a:rPr sz="1150" b="1" i="0">
-                <a:solidFill>
-                  <a:srgbClr val="FAFAF9"/>
-                </a:solidFill>
-                <a:latin typeface="Prompt"/>
-              </a:rPr>
-              <a:t>ACL / NAACL / EMNLP</a:t>
-            </a:r>
-            <a:r>
-              <a:rPr sz="1150" b="0" i="0">
-                <a:solidFill>
-                  <a:srgbClr val="A8A29E"/>
-                </a:solidFill>
-                <a:latin typeface="Prompt"/>
-              </a:rPr>
-              <a:t> = เวทีวิชาการด้านประมวลผลภาษา</a:t>
-            </a:r>
-          </a:p>
-        </p:txBody>
-      </p:sp>
-      <p:sp>
-        <p:nvSpPr>
           <p:cNvPr id="8" name="TextBox 7"/>
           <p:cNvSpPr txBox="1"/>
           <p:nvPr/>
@@ -7159,311 +7078,6 @@
       </p:sp>
       <p:sp>
         <p:nvSpPr>
-          <p:cNvPr id="5" name="TextBox 4"/>
-          <p:cNvSpPr txBox="1"/>
-          <p:nvPr/>
-        </p:nvSpPr>
-        <p:spPr>
-          <a:xfrm>
-            <a:off x="548640" y="1828800"/>
-            <a:ext cx="6766560" cy="3291840"/>
-          </a:xfrm>
-          <a:prstGeom prst="rect">
-            <a:avLst/>
-          </a:prstGeom>
-          <a:noFill/>
-        </p:spPr>
-        <p:txBody>
-          <a:bodyPr wrap="square">
-            <a:spAutoFit/>
-          </a:bodyPr>
-          <a:lstStyle/>
-          <a:p>
-            <a:pPr algn="l">
-              <a:lnSpc>
-                <a:spcPct val="140000"/>
-              </a:lnSpc>
-              <a:spcBef>
-                <a:spcPts val="0"/>
-              </a:spcBef>
-              <a:spcAft>
-                <a:spcPts val="1000"/>
-              </a:spcAft>
-            </a:pPr>
-            <a:r>
-              <a:rPr sz="1600" b="1" i="0" dirty="0">
-                <a:solidFill>
-                  <a:srgbClr val="FBBF24"/>
-                </a:solidFill>
-                <a:latin typeface="Prompt"/>
-              </a:rPr>
-              <a:t>▸ </a:t>
-            </a:r>
-            <a:r>
-              <a:rPr sz="1600" b="1" i="0" dirty="0" err="1">
-                <a:solidFill>
-                  <a:srgbClr val="FAFAF9"/>
-                </a:solidFill>
-                <a:latin typeface="Prompt"/>
-              </a:rPr>
-              <a:t>ความคิดเห็นนับล้าน</a:t>
-            </a:r>
-            <a:r>
-              <a:rPr sz="1600" b="0" i="0" dirty="0">
-                <a:solidFill>
-                  <a:srgbClr val="D6D3D1"/>
-                </a:solidFill>
-                <a:latin typeface="Prompt"/>
-              </a:rPr>
-              <a:t> </a:t>
-            </a:r>
-            <a:r>
-              <a:rPr sz="1600" b="0" i="0" dirty="0" err="1">
-                <a:solidFill>
-                  <a:srgbClr val="D6D3D1"/>
-                </a:solidFill>
-                <a:latin typeface="Prompt"/>
-              </a:rPr>
-              <a:t>ถูกเขียนขึ้นทุกวันบนแพลตฟอร์มออนไลน์</a:t>
-            </a:r>
-            <a:r>
-              <a:rPr sz="1600" b="0" i="0" dirty="0">
-                <a:solidFill>
-                  <a:srgbClr val="D6D3D1"/>
-                </a:solidFill>
-                <a:latin typeface="Prompt"/>
-              </a:rPr>
-              <a:t> — </a:t>
-            </a:r>
-            <a:r>
-              <a:rPr sz="1600" b="0" i="0" dirty="0" err="1">
-                <a:solidFill>
-                  <a:srgbClr val="D6D3D1"/>
-                </a:solidFill>
-                <a:latin typeface="Prompt"/>
-              </a:rPr>
-              <a:t>ธุรกิจต้องรู้ว่าลูกค้า</a:t>
-            </a:r>
-            <a:r>
-              <a:rPr sz="1600" b="0" i="0" dirty="0">
-                <a:solidFill>
-                  <a:srgbClr val="D6D3D1"/>
-                </a:solidFill>
-                <a:latin typeface="Prompt"/>
-              </a:rPr>
-              <a:t> "</a:t>
-            </a:r>
-            <a:r>
-              <a:rPr sz="1600" b="0" i="0" dirty="0" err="1">
-                <a:solidFill>
-                  <a:srgbClr val="D6D3D1"/>
-                </a:solidFill>
-                <a:latin typeface="Prompt"/>
-              </a:rPr>
-              <a:t>รู้สึก</a:t>
-            </a:r>
-            <a:r>
-              <a:rPr sz="1600" b="0" i="0" dirty="0">
-                <a:solidFill>
-                  <a:srgbClr val="D6D3D1"/>
-                </a:solidFill>
-                <a:latin typeface="Prompt"/>
-              </a:rPr>
-              <a:t>" </a:t>
-            </a:r>
-            <a:r>
-              <a:rPr sz="1600" b="0" i="0" dirty="0" err="1">
-                <a:solidFill>
-                  <a:srgbClr val="D6D3D1"/>
-                </a:solidFill>
-                <a:latin typeface="Prompt"/>
-              </a:rPr>
-              <a:t>อย่างไรกับสินค้าและบริการ</a:t>
-            </a:r>
-            <a:endParaRPr sz="1600" b="0" i="0" dirty="0">
-              <a:solidFill>
-                <a:srgbClr val="D6D3D1"/>
-              </a:solidFill>
-              <a:latin typeface="Prompt"/>
-            </a:endParaRPr>
-          </a:p>
-          <a:p>
-            <a:pPr algn="l">
-              <a:lnSpc>
-                <a:spcPct val="140000"/>
-              </a:lnSpc>
-              <a:spcBef>
-                <a:spcPts val="1000"/>
-              </a:spcBef>
-              <a:spcAft>
-                <a:spcPts val="1000"/>
-              </a:spcAft>
-            </a:pPr>
-            <a:r>
-              <a:rPr sz="1600" b="1" i="0" dirty="0">
-                <a:solidFill>
-                  <a:srgbClr val="FBBF24"/>
-                </a:solidFill>
-                <a:latin typeface="Prompt"/>
-              </a:rPr>
-              <a:t>▸ </a:t>
-            </a:r>
-            <a:r>
-              <a:rPr sz="1600" b="1" i="0" dirty="0" err="1">
-                <a:solidFill>
-                  <a:srgbClr val="FAFAF9"/>
-                </a:solidFill>
-                <a:latin typeface="Prompt"/>
-              </a:rPr>
-              <a:t>โมเดลคลาสสิกอย่าง</a:t>
-            </a:r>
-            <a:r>
-              <a:rPr sz="1600" b="1" i="0" dirty="0">
-                <a:solidFill>
-                  <a:srgbClr val="FAFAF9"/>
-                </a:solidFill>
-                <a:latin typeface="Prompt"/>
-              </a:rPr>
-              <a:t> LSTM</a:t>
-            </a:r>
-            <a:r>
-              <a:rPr sz="1600" b="0" i="0" dirty="0">
-                <a:solidFill>
-                  <a:srgbClr val="D6D3D1"/>
-                </a:solidFill>
-                <a:latin typeface="Prompt"/>
-              </a:rPr>
-              <a:t> </a:t>
-            </a:r>
-            <a:r>
-              <a:rPr sz="1600" b="0" i="0" dirty="0" err="1">
-                <a:solidFill>
-                  <a:srgbClr val="D6D3D1"/>
-                </a:solidFill>
-                <a:latin typeface="Prompt"/>
-              </a:rPr>
-              <a:t>เคยเป็นมาตรฐานของงานประมวลผลภาษา</a:t>
-            </a:r>
-            <a:r>
-              <a:rPr sz="1600" b="0" i="0" dirty="0">
-                <a:solidFill>
-                  <a:srgbClr val="D6D3D1"/>
-                </a:solidFill>
-                <a:latin typeface="Prompt"/>
-              </a:rPr>
-              <a:t> </a:t>
-            </a:r>
-            <a:r>
-              <a:rPr sz="1600" b="0" i="0" dirty="0" err="1">
-                <a:solidFill>
-                  <a:srgbClr val="D6D3D1"/>
-                </a:solidFill>
-                <a:latin typeface="Prompt"/>
-              </a:rPr>
-              <a:t>แต่มีข้อจำกัดเชิงโครงสร้างที่แก้ได้ยาก</a:t>
-            </a:r>
-            <a:endParaRPr sz="1600" b="0" i="0" dirty="0">
-              <a:solidFill>
-                <a:srgbClr val="D6D3D1"/>
-              </a:solidFill>
-              <a:latin typeface="Prompt"/>
-            </a:endParaRPr>
-          </a:p>
-          <a:p>
-            <a:pPr algn="l">
-              <a:lnSpc>
-                <a:spcPct val="140000"/>
-              </a:lnSpc>
-              <a:spcBef>
-                <a:spcPts val="1000"/>
-              </a:spcBef>
-              <a:spcAft>
-                <a:spcPts val="1000"/>
-              </a:spcAft>
-            </a:pPr>
-            <a:r>
-              <a:rPr sz="1600" b="1" i="0" dirty="0">
-                <a:solidFill>
-                  <a:srgbClr val="FBBF24"/>
-                </a:solidFill>
-                <a:latin typeface="Prompt"/>
-              </a:rPr>
-              <a:t>▸ </a:t>
-            </a:r>
-            <a:r>
-              <a:rPr sz="1600" b="1" i="0" dirty="0">
-                <a:solidFill>
-                  <a:srgbClr val="FAFAF9"/>
-                </a:solidFill>
-                <a:latin typeface="Prompt"/>
-              </a:rPr>
-              <a:t>Transformer </a:t>
-            </a:r>
-            <a:r>
-              <a:rPr sz="1600" b="1" i="0" dirty="0" err="1">
-                <a:solidFill>
-                  <a:srgbClr val="FAFAF9"/>
-                </a:solidFill>
-                <a:latin typeface="Prompt"/>
-              </a:rPr>
-              <a:t>และ</a:t>
-            </a:r>
-            <a:r>
-              <a:rPr sz="1600" b="1" i="0" dirty="0">
-                <a:solidFill>
-                  <a:srgbClr val="FAFAF9"/>
-                </a:solidFill>
-                <a:latin typeface="Prompt"/>
-              </a:rPr>
-              <a:t> BERT</a:t>
-            </a:r>
-            <a:r>
-              <a:rPr sz="1600" b="0" i="0" dirty="0">
-                <a:solidFill>
-                  <a:srgbClr val="D6D3D1"/>
-                </a:solidFill>
-                <a:latin typeface="Prompt"/>
-              </a:rPr>
-              <a:t> </a:t>
-            </a:r>
-            <a:r>
-              <a:rPr sz="1600" b="0" i="0" dirty="0" err="1">
-                <a:solidFill>
-                  <a:srgbClr val="D6D3D1"/>
-                </a:solidFill>
-                <a:latin typeface="Prompt"/>
-              </a:rPr>
-              <a:t>เปลี่ยนกระบวนทัศน์ด้วยกลไก</a:t>
-            </a:r>
-            <a:r>
-              <a:rPr sz="1600" b="0" i="0" dirty="0">
-                <a:solidFill>
-                  <a:srgbClr val="D6D3D1"/>
-                </a:solidFill>
-                <a:latin typeface="Prompt"/>
-              </a:rPr>
-              <a:t> self-attention — </a:t>
-            </a:r>
-            <a:r>
-              <a:rPr sz="1600" b="0" i="0" dirty="0" err="1">
-                <a:solidFill>
-                  <a:srgbClr val="D6D3D1"/>
-                </a:solidFill>
-                <a:latin typeface="Prompt"/>
-              </a:rPr>
-              <a:t>งานวิจัยนี้พิสูจน์ด้วยตัวเลขจริงว่าต่างกันแค่ไหน</a:t>
-            </a:r>
-            <a:endParaRPr sz="1600" b="0" i="0" dirty="0">
-              <a:solidFill>
-                <a:srgbClr val="D6D3D1"/>
-              </a:solidFill>
-              <a:latin typeface="Prompt"/>
-            </a:endParaRPr>
-          </a:p>
-        </p:txBody>
-      </p:sp>
-      <p:sp>
-        <p:nvSpPr>
           <p:cNvPr id="6" name="Rounded Rectangle 5"/>
           <p:cNvSpPr/>
           <p:nvPr/>
@@ -7582,6 +7196,56 @@
       </p:sp>
       <p:sp>
         <p:nvSpPr>
+          <p:cNvPr id="13" name="Rectangle: Rounded Corners 12">
+            <a:extLst>
+              <a:ext uri="{FF2B5EF4-FFF2-40B4-BE49-F238E27FC236}">
+                <a16:creationId xmlns:a16="http://schemas.microsoft.com/office/drawing/2014/main" id="{908A8D61-3408-BED6-FBB2-4418374241EF}"/>
+              </a:ext>
+            </a:extLst>
+          </p:cNvPr>
+          <p:cNvSpPr/>
+          <p:nvPr/>
+        </p:nvSpPr>
+        <p:spPr>
+          <a:xfrm>
+            <a:off x="459943" y="1766586"/>
+            <a:ext cx="6763817" cy="2389239"/>
+          </a:xfrm>
+          <a:prstGeom prst="roundRect">
+            <a:avLst/>
+          </a:prstGeom>
+          <a:solidFill>
+            <a:schemeClr val="tx1">
+              <a:lumMod val="85000"/>
+              <a:lumOff val="15000"/>
+            </a:schemeClr>
+          </a:solidFill>
+        </p:spPr>
+        <p:style>
+          <a:lnRef idx="2">
+            <a:schemeClr val="dk1"/>
+          </a:lnRef>
+          <a:fillRef idx="1">
+            <a:schemeClr val="lt1"/>
+          </a:fillRef>
+          <a:effectRef idx="0">
+            <a:schemeClr val="dk1"/>
+          </a:effectRef>
+          <a:fontRef idx="minor">
+            <a:schemeClr val="dk1"/>
+          </a:fontRef>
+        </p:style>
+        <p:txBody>
+          <a:bodyPr rtlCol="0" anchor="ctr"/>
+          <a:lstStyle/>
+          <a:p>
+            <a:pPr algn="ctr"/>
+            <a:endParaRPr lang="th-TH"/>
+          </a:p>
+        </p:txBody>
+      </p:sp>
+      <p:sp>
+        <p:nvSpPr>
           <p:cNvPr id="8" name="Rounded Rectangle 7"/>
           <p:cNvSpPr/>
           <p:nvPr/>
@@ -8000,6 +7664,311 @@
               </a:rPr>
               <a:t>02 / 13</a:t>
             </a:r>
+          </a:p>
+        </p:txBody>
+      </p:sp>
+      <p:sp>
+        <p:nvSpPr>
+          <p:cNvPr id="5" name="TextBox 4"/>
+          <p:cNvSpPr txBox="1"/>
+          <p:nvPr/>
+        </p:nvSpPr>
+        <p:spPr>
+          <a:xfrm>
+            <a:off x="548640" y="1801368"/>
+            <a:ext cx="6766560" cy="3291840"/>
+          </a:xfrm>
+          <a:prstGeom prst="rect">
+            <a:avLst/>
+          </a:prstGeom>
+          <a:noFill/>
+        </p:spPr>
+        <p:txBody>
+          <a:bodyPr wrap="square">
+            <a:spAutoFit/>
+          </a:bodyPr>
+          <a:lstStyle/>
+          <a:p>
+            <a:pPr algn="l">
+              <a:lnSpc>
+                <a:spcPct val="140000"/>
+              </a:lnSpc>
+              <a:spcBef>
+                <a:spcPts val="0"/>
+              </a:spcBef>
+              <a:spcAft>
+                <a:spcPts val="1000"/>
+              </a:spcAft>
+            </a:pPr>
+            <a:r>
+              <a:rPr sz="1600" b="1" i="0" dirty="0">
+                <a:solidFill>
+                  <a:srgbClr val="FBBF24"/>
+                </a:solidFill>
+                <a:latin typeface="Prompt"/>
+              </a:rPr>
+              <a:t>▸ </a:t>
+            </a:r>
+            <a:r>
+              <a:rPr sz="1600" b="1" i="0" dirty="0" err="1">
+                <a:solidFill>
+                  <a:srgbClr val="FAFAF9"/>
+                </a:solidFill>
+                <a:latin typeface="Prompt"/>
+              </a:rPr>
+              <a:t>ความคิดเห็นนับล้าน</a:t>
+            </a:r>
+            <a:r>
+              <a:rPr sz="1600" b="0" i="0" dirty="0">
+                <a:solidFill>
+                  <a:srgbClr val="D6D3D1"/>
+                </a:solidFill>
+                <a:latin typeface="Prompt"/>
+              </a:rPr>
+              <a:t> </a:t>
+            </a:r>
+            <a:r>
+              <a:rPr sz="1600" b="0" i="0" dirty="0" err="1">
+                <a:solidFill>
+                  <a:srgbClr val="D6D3D1"/>
+                </a:solidFill>
+                <a:latin typeface="Prompt"/>
+              </a:rPr>
+              <a:t>ถูกเขียนขึ้นทุกวันบนแพลตฟอร์มออนไลน์</a:t>
+            </a:r>
+            <a:r>
+              <a:rPr sz="1600" b="0" i="0" dirty="0">
+                <a:solidFill>
+                  <a:srgbClr val="D6D3D1"/>
+                </a:solidFill>
+                <a:latin typeface="Prompt"/>
+              </a:rPr>
+              <a:t> — </a:t>
+            </a:r>
+            <a:r>
+              <a:rPr sz="1600" b="0" i="0" dirty="0" err="1">
+                <a:solidFill>
+                  <a:srgbClr val="D6D3D1"/>
+                </a:solidFill>
+                <a:latin typeface="Prompt"/>
+              </a:rPr>
+              <a:t>ธุรกิจต้องรู้ว่าลูกค้า</a:t>
+            </a:r>
+            <a:r>
+              <a:rPr sz="1600" b="0" i="0" dirty="0">
+                <a:solidFill>
+                  <a:srgbClr val="D6D3D1"/>
+                </a:solidFill>
+                <a:latin typeface="Prompt"/>
+              </a:rPr>
+              <a:t> "</a:t>
+            </a:r>
+            <a:r>
+              <a:rPr sz="1600" b="0" i="0" dirty="0" err="1">
+                <a:solidFill>
+                  <a:srgbClr val="D6D3D1"/>
+                </a:solidFill>
+                <a:latin typeface="Prompt"/>
+              </a:rPr>
+              <a:t>รู้สึก</a:t>
+            </a:r>
+            <a:r>
+              <a:rPr sz="1600" b="0" i="0" dirty="0">
+                <a:solidFill>
+                  <a:srgbClr val="D6D3D1"/>
+                </a:solidFill>
+                <a:latin typeface="Prompt"/>
+              </a:rPr>
+              <a:t>" </a:t>
+            </a:r>
+            <a:r>
+              <a:rPr sz="1600" b="0" i="0" dirty="0" err="1">
+                <a:solidFill>
+                  <a:srgbClr val="D6D3D1"/>
+                </a:solidFill>
+                <a:latin typeface="Prompt"/>
+              </a:rPr>
+              <a:t>อย่างไรกับสินค้าและบริการ</a:t>
+            </a:r>
+            <a:endParaRPr sz="1600" b="0" i="0" dirty="0">
+              <a:solidFill>
+                <a:srgbClr val="D6D3D1"/>
+              </a:solidFill>
+              <a:latin typeface="Prompt"/>
+            </a:endParaRPr>
+          </a:p>
+          <a:p>
+            <a:pPr algn="l">
+              <a:lnSpc>
+                <a:spcPct val="140000"/>
+              </a:lnSpc>
+              <a:spcBef>
+                <a:spcPts val="1000"/>
+              </a:spcBef>
+              <a:spcAft>
+                <a:spcPts val="1000"/>
+              </a:spcAft>
+            </a:pPr>
+            <a:r>
+              <a:rPr sz="1600" b="1" i="0" dirty="0">
+                <a:solidFill>
+                  <a:srgbClr val="FBBF24"/>
+                </a:solidFill>
+                <a:latin typeface="Prompt"/>
+              </a:rPr>
+              <a:t>▸ </a:t>
+            </a:r>
+            <a:r>
+              <a:rPr sz="1600" b="1" i="0" dirty="0" err="1">
+                <a:solidFill>
+                  <a:srgbClr val="FAFAF9"/>
+                </a:solidFill>
+                <a:latin typeface="Prompt"/>
+              </a:rPr>
+              <a:t>โมเดลคลาสสิกอย่าง</a:t>
+            </a:r>
+            <a:r>
+              <a:rPr sz="1600" b="1" i="0" dirty="0">
+                <a:solidFill>
+                  <a:srgbClr val="FAFAF9"/>
+                </a:solidFill>
+                <a:latin typeface="Prompt"/>
+              </a:rPr>
+              <a:t> LSTM</a:t>
+            </a:r>
+            <a:r>
+              <a:rPr sz="1600" b="0" i="0" dirty="0">
+                <a:solidFill>
+                  <a:srgbClr val="D6D3D1"/>
+                </a:solidFill>
+                <a:latin typeface="Prompt"/>
+              </a:rPr>
+              <a:t> </a:t>
+            </a:r>
+            <a:r>
+              <a:rPr sz="1600" b="0" i="0" dirty="0" err="1">
+                <a:solidFill>
+                  <a:srgbClr val="D6D3D1"/>
+                </a:solidFill>
+                <a:latin typeface="Prompt"/>
+              </a:rPr>
+              <a:t>เคยเป็นมาตรฐานของงานประมวลผลภาษา</a:t>
+            </a:r>
+            <a:r>
+              <a:rPr sz="1600" b="0" i="0" dirty="0">
+                <a:solidFill>
+                  <a:srgbClr val="D6D3D1"/>
+                </a:solidFill>
+                <a:latin typeface="Prompt"/>
+              </a:rPr>
+              <a:t> </a:t>
+            </a:r>
+            <a:r>
+              <a:rPr sz="1600" b="0" i="0" dirty="0" err="1">
+                <a:solidFill>
+                  <a:srgbClr val="D6D3D1"/>
+                </a:solidFill>
+                <a:latin typeface="Prompt"/>
+              </a:rPr>
+              <a:t>แต่มีข้อจำกัดเชิงโครงสร้างที่แก้ได้ยาก</a:t>
+            </a:r>
+            <a:endParaRPr sz="1600" b="0" i="0" dirty="0">
+              <a:solidFill>
+                <a:srgbClr val="D6D3D1"/>
+              </a:solidFill>
+              <a:latin typeface="Prompt"/>
+            </a:endParaRPr>
+          </a:p>
+          <a:p>
+            <a:pPr algn="l">
+              <a:lnSpc>
+                <a:spcPct val="140000"/>
+              </a:lnSpc>
+              <a:spcBef>
+                <a:spcPts val="1000"/>
+              </a:spcBef>
+              <a:spcAft>
+                <a:spcPts val="1000"/>
+              </a:spcAft>
+            </a:pPr>
+            <a:r>
+              <a:rPr sz="1600" b="1" i="0" dirty="0">
+                <a:solidFill>
+                  <a:srgbClr val="FBBF24"/>
+                </a:solidFill>
+                <a:latin typeface="Prompt"/>
+              </a:rPr>
+              <a:t>▸ </a:t>
+            </a:r>
+            <a:r>
+              <a:rPr sz="1600" b="1" i="0" dirty="0">
+                <a:solidFill>
+                  <a:srgbClr val="FAFAF9"/>
+                </a:solidFill>
+                <a:latin typeface="Prompt"/>
+              </a:rPr>
+              <a:t>Transformer </a:t>
+            </a:r>
+            <a:r>
+              <a:rPr sz="1600" b="1" i="0" dirty="0" err="1">
+                <a:solidFill>
+                  <a:srgbClr val="FAFAF9"/>
+                </a:solidFill>
+                <a:latin typeface="Prompt"/>
+              </a:rPr>
+              <a:t>และ</a:t>
+            </a:r>
+            <a:r>
+              <a:rPr sz="1600" b="1" i="0" dirty="0">
+                <a:solidFill>
+                  <a:srgbClr val="FAFAF9"/>
+                </a:solidFill>
+                <a:latin typeface="Prompt"/>
+              </a:rPr>
+              <a:t> BERT</a:t>
+            </a:r>
+            <a:r>
+              <a:rPr sz="1600" b="0" i="0" dirty="0">
+                <a:solidFill>
+                  <a:srgbClr val="D6D3D1"/>
+                </a:solidFill>
+                <a:latin typeface="Prompt"/>
+              </a:rPr>
+              <a:t> </a:t>
+            </a:r>
+            <a:r>
+              <a:rPr sz="1600" b="0" i="0" dirty="0" err="1">
+                <a:solidFill>
+                  <a:srgbClr val="D6D3D1"/>
+                </a:solidFill>
+                <a:latin typeface="Prompt"/>
+              </a:rPr>
+              <a:t>เปลี่ยนกระบวนทัศน์ด้วยกลไก</a:t>
+            </a:r>
+            <a:r>
+              <a:rPr sz="1600" b="0" i="0" dirty="0">
+                <a:solidFill>
+                  <a:srgbClr val="D6D3D1"/>
+                </a:solidFill>
+                <a:latin typeface="Prompt"/>
+              </a:rPr>
+              <a:t> self-attention — </a:t>
+            </a:r>
+            <a:r>
+              <a:rPr sz="1600" b="0" i="0" dirty="0" err="1">
+                <a:solidFill>
+                  <a:srgbClr val="D6D3D1"/>
+                </a:solidFill>
+                <a:latin typeface="Prompt"/>
+              </a:rPr>
+              <a:t>งานวิจัยนี้พิสูจน์ด้วยตัวเลขจริงว่าต่างกันแค่ไหน</a:t>
+            </a:r>
+            <a:endParaRPr sz="1600" b="0" i="0" dirty="0">
+              <a:solidFill>
+                <a:srgbClr val="D6D3D1"/>
+              </a:solidFill>
+              <a:latin typeface="Prompt"/>
+            </a:endParaRPr>
           </a:p>
         </p:txBody>
       </p:sp>
@@ -8069,6 +8038,56 @@
           <a:p>
             <a:pPr algn="ctr"/>
             <a:endParaRPr/>
+          </a:p>
+        </p:txBody>
+      </p:sp>
+      <p:sp>
+        <p:nvSpPr>
+          <p:cNvPr id="26" name="Rectangle: Rounded Corners 25">
+            <a:extLst>
+              <a:ext uri="{FF2B5EF4-FFF2-40B4-BE49-F238E27FC236}">
+                <a16:creationId xmlns:a16="http://schemas.microsoft.com/office/drawing/2014/main" id="{945214F1-E9C8-3EC0-8EC4-E7E063269B50}"/>
+              </a:ext>
+            </a:extLst>
+          </p:cNvPr>
+          <p:cNvSpPr/>
+          <p:nvPr/>
+        </p:nvSpPr>
+        <p:spPr>
+          <a:xfrm>
+            <a:off x="545690" y="4577901"/>
+            <a:ext cx="3598607" cy="1482542"/>
+          </a:xfrm>
+          <a:prstGeom prst="roundRect">
+            <a:avLst/>
+          </a:prstGeom>
+          <a:solidFill>
+            <a:schemeClr val="tx1">
+              <a:lumMod val="85000"/>
+              <a:lumOff val="15000"/>
+            </a:schemeClr>
+          </a:solidFill>
+        </p:spPr>
+        <p:style>
+          <a:lnRef idx="2">
+            <a:schemeClr val="dk1"/>
+          </a:lnRef>
+          <a:fillRef idx="1">
+            <a:schemeClr val="lt1"/>
+          </a:fillRef>
+          <a:effectRef idx="0">
+            <a:schemeClr val="dk1"/>
+          </a:effectRef>
+          <a:fontRef idx="minor">
+            <a:schemeClr val="dk1"/>
+          </a:fontRef>
+        </p:style>
+        <p:txBody>
+          <a:bodyPr rtlCol="0" anchor="ctr"/>
+          <a:lstStyle/>
+          <a:p>
+            <a:pPr algn="ctr"/>
+            <a:endParaRPr lang="th-TH"/>
           </a:p>
         </p:txBody>
       </p:sp>

</xml_diff>